<commit_message>
updated sensitivity labels to Public for decks, moved AI Gateway from notebook 2 to 8
</commit_message>
<xml_diff>
--- a/decks/Microsoft Foundry Content-Understanding.pptx
+++ b/decks/Microsoft Foundry Content-Understanding.pptx
@@ -218,7 +218,7 @@
           </a:lstStyle>
           <a:p>
             <a:fld id="{E7151A7F-A218-400D-B2AA-FF76126F9EDB}" type="datetimeFigureOut">
-              <a:t>9/30/2026</a:t>
+              <a:t>11/10/2026</a:t>
             </a:fld>
             <a:endParaRPr lang="en-US"/>
           </a:p>
@@ -1719,7 +1719,7 @@
           <a:p>
             <a:fld id="{5BCAD085-E8A6-8845-BD4E-CB4CCA059FC4}" type="datetimeFigureOut">
               <a:rPr lang="en-US" smtClean="0"/>
-              <a:t>9/30/2026</a:t>
+              <a:t>10/11/2026</a:t>
             </a:fld>
             <a:endParaRPr lang="en-US"/>
           </a:p>
@@ -1887,7 +1887,7 @@
           <a:p>
             <a:fld id="{5BCAD085-E8A6-8845-BD4E-CB4CCA059FC4}" type="datetimeFigureOut">
               <a:rPr lang="en-US" smtClean="0"/>
-              <a:t>9/30/2026</a:t>
+              <a:t>10/11/2026</a:t>
             </a:fld>
             <a:endParaRPr lang="en-US"/>
           </a:p>
@@ -2065,7 +2065,7 @@
           <a:p>
             <a:fld id="{5BCAD085-E8A6-8845-BD4E-CB4CCA059FC4}" type="datetimeFigureOut">
               <a:rPr lang="en-US" smtClean="0"/>
-              <a:t>9/30/2026</a:t>
+              <a:t>10/11/2026</a:t>
             </a:fld>
             <a:endParaRPr lang="en-US"/>
           </a:p>
@@ -2233,7 +2233,7 @@
           <a:p>
             <a:fld id="{5BCAD085-E8A6-8845-BD4E-CB4CCA059FC4}" type="datetimeFigureOut">
               <a:rPr lang="en-US" smtClean="0"/>
-              <a:t>9/30/2026</a:t>
+              <a:t>10/11/2026</a:t>
             </a:fld>
             <a:endParaRPr lang="en-US"/>
           </a:p>
@@ -2478,7 +2478,7 @@
           <a:p>
             <a:fld id="{5BCAD085-E8A6-8845-BD4E-CB4CCA059FC4}" type="datetimeFigureOut">
               <a:rPr lang="en-US" smtClean="0"/>
-              <a:t>9/30/2026</a:t>
+              <a:t>10/11/2026</a:t>
             </a:fld>
             <a:endParaRPr lang="en-US"/>
           </a:p>
@@ -2763,7 +2763,7 @@
           <a:p>
             <a:fld id="{5BCAD085-E8A6-8845-BD4E-CB4CCA059FC4}" type="datetimeFigureOut">
               <a:rPr lang="en-US" smtClean="0"/>
-              <a:t>9/30/2026</a:t>
+              <a:t>10/11/2026</a:t>
             </a:fld>
             <a:endParaRPr lang="en-US"/>
           </a:p>
@@ -3182,7 +3182,7 @@
           <a:p>
             <a:fld id="{5BCAD085-E8A6-8845-BD4E-CB4CCA059FC4}" type="datetimeFigureOut">
               <a:rPr lang="en-US" smtClean="0"/>
-              <a:t>9/30/2026</a:t>
+              <a:t>10/11/2026</a:t>
             </a:fld>
             <a:endParaRPr lang="en-US"/>
           </a:p>
@@ -3299,7 +3299,7 @@
           <a:p>
             <a:fld id="{5BCAD085-E8A6-8845-BD4E-CB4CCA059FC4}" type="datetimeFigureOut">
               <a:rPr lang="en-US" smtClean="0"/>
-              <a:t>9/30/2026</a:t>
+              <a:t>10/11/2026</a:t>
             </a:fld>
             <a:endParaRPr lang="en-US"/>
           </a:p>
@@ -3394,7 +3394,7 @@
           <a:p>
             <a:fld id="{5BCAD085-E8A6-8845-BD4E-CB4CCA059FC4}" type="datetimeFigureOut">
               <a:rPr lang="en-US" smtClean="0"/>
-              <a:t>9/30/2026</a:t>
+              <a:t>10/11/2026</a:t>
             </a:fld>
             <a:endParaRPr lang="en-US"/>
           </a:p>
@@ -3669,7 +3669,7 @@
           <a:p>
             <a:fld id="{5BCAD085-E8A6-8845-BD4E-CB4CCA059FC4}" type="datetimeFigureOut">
               <a:rPr lang="en-US" smtClean="0"/>
-              <a:t>9/30/2026</a:t>
+              <a:t>10/11/2026</a:t>
             </a:fld>
             <a:endParaRPr lang="en-US"/>
           </a:p>
@@ -3921,7 +3921,7 @@
           <a:p>
             <a:fld id="{5BCAD085-E8A6-8845-BD4E-CB4CCA059FC4}" type="datetimeFigureOut">
               <a:rPr lang="en-US" smtClean="0"/>
-              <a:t>9/30/2026</a:t>
+              <a:t>10/11/2026</a:t>
             </a:fld>
             <a:endParaRPr lang="en-US"/>
           </a:p>
@@ -4132,7 +4132,7 @@
           <a:p>
             <a:fld id="{5BCAD085-E8A6-8845-BD4E-CB4CCA059FC4}" type="datetimeFigureOut">
               <a:rPr lang="en-US" smtClean="0"/>
-              <a:t>9/30/2026</a:t>
+              <a:t>10/11/2026</a:t>
             </a:fld>
             <a:endParaRPr lang="en-US"/>
           </a:p>
@@ -5040,7 +5040,7 @@
         <p:spPr>
           <a:xfrm>
             <a:off x="914400" y="5897880"/>
-            <a:ext cx="7315200" cy="182880"/>
+            <a:ext cx="7315200" cy="146194"/>
           </a:xfrm>
           <a:prstGeom prst="rect">
             <a:avLst/>
@@ -5059,55 +5059,22 @@
               </a:lnSpc>
             </a:pPr>
             <a:r>
-              <a:rPr sz="950" b="0" i="0" dirty="0">
+              <a:rPr lang="en-GB" sz="950" b="0" i="0" dirty="0">
                 <a:solidFill>
                   <a:srgbClr val="B9C2D6"/>
                 </a:solidFill>
                 <a:latin typeface="Segoe UI"/>
                 <a:cs typeface="Segoe UI"/>
               </a:rPr>
-              <a:t>Alex Sachelarescu  ·  Cloud Solution Architect, Azure</a:t>
-            </a:r>
-          </a:p>
-        </p:txBody>
-      </p:sp>
-      <p:sp>
-        <p:nvSpPr>
-          <p:cNvPr id="15" name="TextBox 14"/>
-          <p:cNvSpPr txBox="1"/>
-          <p:nvPr/>
-        </p:nvSpPr>
-        <p:spPr>
-          <a:xfrm>
-            <a:off x="8412480" y="5897880"/>
-            <a:ext cx="2864815" cy="182880"/>
-          </a:xfrm>
-          <a:prstGeom prst="rect">
-            <a:avLst/>
-          </a:prstGeom>
-          <a:noFill/>
-        </p:spPr>
-        <p:txBody>
-          <a:bodyPr wrap="square" lIns="0" tIns="0" rIns="0" bIns="0" anchor="t">
-            <a:spAutoFit/>
-          </a:bodyPr>
-          <a:lstStyle/>
-          <a:p>
-            <a:pPr algn="r">
-              <a:lnSpc>
-                <a:spcPct val="100000"/>
-              </a:lnSpc>
-            </a:pPr>
-            <a:r>
-              <a:rPr sz="950" b="0" i="0" dirty="0">
-                <a:solidFill>
-                  <a:srgbClr val="B9C2D6"/>
-                </a:solidFill>
-                <a:latin typeface="Segoe UI"/>
-                <a:cs typeface="Segoe UI"/>
-              </a:rPr>
               <a:t>September 2026</a:t>
             </a:r>
+            <a:endParaRPr sz="950" b="0" i="0" dirty="0">
+              <a:solidFill>
+                <a:srgbClr val="B9C2D6"/>
+              </a:solidFill>
+              <a:latin typeface="Segoe UI"/>
+              <a:cs typeface="Segoe UI"/>
+            </a:endParaRPr>
           </a:p>
         </p:txBody>
       </p:sp>
@@ -29156,6 +29123,6 @@
 
 <file path=docMetadata/LabelInfo.xml><?xml version="1.0" encoding="utf-8"?>
 <clbl:labelList xmlns:clbl="http://schemas.microsoft.com/office/2020/mipLabelMetadata">
-  <clbl:label id="{f42aa342-8706-4288-bd11-ebb85995028c}" enabled="1" method="Standard" siteId="{72f988bf-86f1-41af-91ab-2d7cd011db47}" contentBits="0" removed="0"/>
+  <clbl:label id="{87867195-f2b8-4ac2-b0b6-6bb73cb33afc}" enabled="1" method="Privileged" siteId="{72f988bf-86f1-41af-91ab-2d7cd011db47}" contentBits="0" removed="0"/>
 </clbl:labelList>
 </file>
</xml_diff>